<commit_message>
Generate first repository video batch
</commit_message>
<xml_diff>
--- a/public/videos/repositories/togo-kanri-tool/togo-kanri-tool-tech-preview.pptx
+++ b/public/videos/repositories/togo-kanri-tool/togo-kanri-tool-tech-preview.pptx
@@ -134,7 +134,7 @@
           <p:cNvPr id="2" name="タイトル 1">
             <a:extLst>
               <a:ext uri="{FF2B5EF4-FFF2-40B4-BE49-F238E27FC236}">
-                <a16:creationId xmlns:a16="http://schemas.microsoft.com/office/drawing/2014/main" id="{144DD5FD-F9D0-0F17-68A8-B770440AF956}"/>
+                <a16:creationId xmlns:a16="http://schemas.microsoft.com/office/drawing/2014/main" id="{9AFE3E65-40C9-7BB2-3180-08BD0793F4EC}"/>
               </a:ext>
             </a:extLst>
           </p:cNvPr>
@@ -171,7 +171,7 @@
           <p:cNvPr id="3" name="字幕 2">
             <a:extLst>
               <a:ext uri="{FF2B5EF4-FFF2-40B4-BE49-F238E27FC236}">
-                <a16:creationId xmlns:a16="http://schemas.microsoft.com/office/drawing/2014/main" id="{988C4CA5-1574-9F3B-E3DD-DAB95533D491}"/>
+                <a16:creationId xmlns:a16="http://schemas.microsoft.com/office/drawing/2014/main" id="{E103D128-0096-EAA3-D9FA-FBABAFA4B431}"/>
               </a:ext>
             </a:extLst>
           </p:cNvPr>
@@ -241,7 +241,7 @@
           <p:cNvPr id="4" name="日付プレースホルダー 3">
             <a:extLst>
               <a:ext uri="{FF2B5EF4-FFF2-40B4-BE49-F238E27FC236}">
-                <a16:creationId xmlns:a16="http://schemas.microsoft.com/office/drawing/2014/main" id="{A6753E41-16B6-9DD4-A449-D85931E07686}"/>
+                <a16:creationId xmlns:a16="http://schemas.microsoft.com/office/drawing/2014/main" id="{0C450B4C-D489-62BB-42A5-E51E70CFC3CE}"/>
               </a:ext>
             </a:extLst>
           </p:cNvPr>
@@ -257,7 +257,7 @@
           <a:bodyPr/>
           <a:lstStyle/>
           <a:p>
-            <a:fld id="{38CF951B-9A95-4A04-A553-A9E1FF600C98}" type="datetimeFigureOut">
+            <a:fld id="{548A954F-6878-4CBB-85A4-08585DEC05C9}" type="datetimeFigureOut">
               <a:rPr kumimoji="1" lang="ja-JP" altLang="en-US" smtClean="0"/>
               <a:t>2026/7/30</a:t>
             </a:fld>
@@ -270,7 +270,7 @@
           <p:cNvPr id="5" name="フッター プレースホルダー 4">
             <a:extLst>
               <a:ext uri="{FF2B5EF4-FFF2-40B4-BE49-F238E27FC236}">
-                <a16:creationId xmlns:a16="http://schemas.microsoft.com/office/drawing/2014/main" id="{162FB68E-B117-C22B-B12D-794B0F76538D}"/>
+                <a16:creationId xmlns:a16="http://schemas.microsoft.com/office/drawing/2014/main" id="{906EEDDB-598C-D747-0130-D8890D855EC3}"/>
               </a:ext>
             </a:extLst>
           </p:cNvPr>
@@ -295,7 +295,7 @@
           <p:cNvPr id="6" name="スライド番号プレースホルダー 5">
             <a:extLst>
               <a:ext uri="{FF2B5EF4-FFF2-40B4-BE49-F238E27FC236}">
-                <a16:creationId xmlns:a16="http://schemas.microsoft.com/office/drawing/2014/main" id="{BD319691-3A8F-B05E-8C00-456E0E13ADDB}"/>
+                <a16:creationId xmlns:a16="http://schemas.microsoft.com/office/drawing/2014/main" id="{42600586-F2B9-D6CC-FE2A-8E1549A54E0B}"/>
               </a:ext>
             </a:extLst>
           </p:cNvPr>
@@ -311,7 +311,7 @@
           <a:bodyPr/>
           <a:lstStyle/>
           <a:p>
-            <a:fld id="{8B3C9EF3-6771-44E9-A7A2-47E6107873BF}" type="slidenum">
+            <a:fld id="{6B2941EB-36E4-47D0-8598-D5AE01190ABB}" type="slidenum">
               <a:rPr kumimoji="1" lang="ja-JP" altLang="en-US" smtClean="0"/>
               <a:t>‹#›</a:t>
             </a:fld>
@@ -322,7 +322,7 @@
     </p:spTree>
     <p:extLst>
       <p:ext uri="{BB962C8B-B14F-4D97-AF65-F5344CB8AC3E}">
-        <p14:creationId xmlns:p14="http://schemas.microsoft.com/office/powerpoint/2010/main" val="3612846971"/>
+        <p14:creationId xmlns:p14="http://schemas.microsoft.com/office/powerpoint/2010/main" val="2830542795"/>
       </p:ext>
     </p:extLst>
   </p:cSld>
@@ -354,7 +354,7 @@
           <p:cNvPr id="2" name="タイトル 1">
             <a:extLst>
               <a:ext uri="{FF2B5EF4-FFF2-40B4-BE49-F238E27FC236}">
-                <a16:creationId xmlns:a16="http://schemas.microsoft.com/office/drawing/2014/main" id="{6D4EAE5D-F0DF-FBB9-3F8F-37DBF05091C6}"/>
+                <a16:creationId xmlns:a16="http://schemas.microsoft.com/office/drawing/2014/main" id="{873F183B-51ED-787B-5953-9AEE5294ED3E}"/>
               </a:ext>
             </a:extLst>
           </p:cNvPr>
@@ -382,7 +382,7 @@
           <p:cNvPr id="3" name="縦書きテキスト プレースホルダー 2">
             <a:extLst>
               <a:ext uri="{FF2B5EF4-FFF2-40B4-BE49-F238E27FC236}">
-                <a16:creationId xmlns:a16="http://schemas.microsoft.com/office/drawing/2014/main" id="{919715D9-DA66-89A8-DDF6-A9E19A2C4761}"/>
+                <a16:creationId xmlns:a16="http://schemas.microsoft.com/office/drawing/2014/main" id="{79955776-40F8-F2CC-0A22-FA665C9DF948}"/>
               </a:ext>
             </a:extLst>
           </p:cNvPr>
@@ -471,7 +471,7 @@
           <p:cNvPr id="4" name="日付プレースホルダー 3">
             <a:extLst>
               <a:ext uri="{FF2B5EF4-FFF2-40B4-BE49-F238E27FC236}">
-                <a16:creationId xmlns:a16="http://schemas.microsoft.com/office/drawing/2014/main" id="{8494A251-0E94-4B24-A09C-F438E2D31599}"/>
+                <a16:creationId xmlns:a16="http://schemas.microsoft.com/office/drawing/2014/main" id="{060BAEA9-F7F2-A728-126F-B8D4D650E10E}"/>
               </a:ext>
             </a:extLst>
           </p:cNvPr>
@@ -487,7 +487,7 @@
           <a:bodyPr/>
           <a:lstStyle/>
           <a:p>
-            <a:fld id="{38CF951B-9A95-4A04-A553-A9E1FF600C98}" type="datetimeFigureOut">
+            <a:fld id="{548A954F-6878-4CBB-85A4-08585DEC05C9}" type="datetimeFigureOut">
               <a:rPr kumimoji="1" lang="ja-JP" altLang="en-US" smtClean="0"/>
               <a:t>2026/7/30</a:t>
             </a:fld>
@@ -500,7 +500,7 @@
           <p:cNvPr id="5" name="フッター プレースホルダー 4">
             <a:extLst>
               <a:ext uri="{FF2B5EF4-FFF2-40B4-BE49-F238E27FC236}">
-                <a16:creationId xmlns:a16="http://schemas.microsoft.com/office/drawing/2014/main" id="{E9B6970D-7B8B-D676-D7A0-D1190FB6B810}"/>
+                <a16:creationId xmlns:a16="http://schemas.microsoft.com/office/drawing/2014/main" id="{6FB6A6C4-74ED-558E-9477-822B29E5E77B}"/>
               </a:ext>
             </a:extLst>
           </p:cNvPr>
@@ -525,7 +525,7 @@
           <p:cNvPr id="6" name="スライド番号プレースホルダー 5">
             <a:extLst>
               <a:ext uri="{FF2B5EF4-FFF2-40B4-BE49-F238E27FC236}">
-                <a16:creationId xmlns:a16="http://schemas.microsoft.com/office/drawing/2014/main" id="{21745312-0F3B-C1E7-0AED-47C207706A92}"/>
+                <a16:creationId xmlns:a16="http://schemas.microsoft.com/office/drawing/2014/main" id="{7268CD16-B420-703A-CA92-56CD357E0B83}"/>
               </a:ext>
             </a:extLst>
           </p:cNvPr>
@@ -541,7 +541,7 @@
           <a:bodyPr/>
           <a:lstStyle/>
           <a:p>
-            <a:fld id="{8B3C9EF3-6771-44E9-A7A2-47E6107873BF}" type="slidenum">
+            <a:fld id="{6B2941EB-36E4-47D0-8598-D5AE01190ABB}" type="slidenum">
               <a:rPr kumimoji="1" lang="ja-JP" altLang="en-US" smtClean="0"/>
               <a:t>‹#›</a:t>
             </a:fld>
@@ -552,7 +552,7 @@
     </p:spTree>
     <p:extLst>
       <p:ext uri="{BB962C8B-B14F-4D97-AF65-F5344CB8AC3E}">
-        <p14:creationId xmlns:p14="http://schemas.microsoft.com/office/powerpoint/2010/main" val="4261437847"/>
+        <p14:creationId xmlns:p14="http://schemas.microsoft.com/office/powerpoint/2010/main" val="2512260682"/>
       </p:ext>
     </p:extLst>
   </p:cSld>
@@ -584,7 +584,7 @@
           <p:cNvPr id="2" name="縦書きタイトル 1">
             <a:extLst>
               <a:ext uri="{FF2B5EF4-FFF2-40B4-BE49-F238E27FC236}">
-                <a16:creationId xmlns:a16="http://schemas.microsoft.com/office/drawing/2014/main" id="{7D710124-45F3-6A27-5686-07FB8893AB33}"/>
+                <a16:creationId xmlns:a16="http://schemas.microsoft.com/office/drawing/2014/main" id="{53816280-9217-02A5-EBA8-A987163463F8}"/>
               </a:ext>
             </a:extLst>
           </p:cNvPr>
@@ -617,7 +617,7 @@
           <p:cNvPr id="3" name="縦書きテキスト プレースホルダー 2">
             <a:extLst>
               <a:ext uri="{FF2B5EF4-FFF2-40B4-BE49-F238E27FC236}">
-                <a16:creationId xmlns:a16="http://schemas.microsoft.com/office/drawing/2014/main" id="{CA8BFE43-F170-4677-4418-5A899F46DE03}"/>
+                <a16:creationId xmlns:a16="http://schemas.microsoft.com/office/drawing/2014/main" id="{5A2385CF-84FC-4ABE-0C2A-F55AB6649C1E}"/>
               </a:ext>
             </a:extLst>
           </p:cNvPr>
@@ -711,7 +711,7 @@
           <p:cNvPr id="4" name="日付プレースホルダー 3">
             <a:extLst>
               <a:ext uri="{FF2B5EF4-FFF2-40B4-BE49-F238E27FC236}">
-                <a16:creationId xmlns:a16="http://schemas.microsoft.com/office/drawing/2014/main" id="{B8799153-5A7F-767C-6A00-8016B4DBC5BC}"/>
+                <a16:creationId xmlns:a16="http://schemas.microsoft.com/office/drawing/2014/main" id="{5BB09E59-C170-BCEF-F855-D53328EF3801}"/>
               </a:ext>
             </a:extLst>
           </p:cNvPr>
@@ -727,7 +727,7 @@
           <a:bodyPr/>
           <a:lstStyle/>
           <a:p>
-            <a:fld id="{38CF951B-9A95-4A04-A553-A9E1FF600C98}" type="datetimeFigureOut">
+            <a:fld id="{548A954F-6878-4CBB-85A4-08585DEC05C9}" type="datetimeFigureOut">
               <a:rPr kumimoji="1" lang="ja-JP" altLang="en-US" smtClean="0"/>
               <a:t>2026/7/30</a:t>
             </a:fld>
@@ -740,7 +740,7 @@
           <p:cNvPr id="5" name="フッター プレースホルダー 4">
             <a:extLst>
               <a:ext uri="{FF2B5EF4-FFF2-40B4-BE49-F238E27FC236}">
-                <a16:creationId xmlns:a16="http://schemas.microsoft.com/office/drawing/2014/main" id="{3885CBDF-0EBC-4646-9DB7-6F5A568A12BA}"/>
+                <a16:creationId xmlns:a16="http://schemas.microsoft.com/office/drawing/2014/main" id="{E3927A0D-6FE2-9629-5698-99B387EEEA93}"/>
               </a:ext>
             </a:extLst>
           </p:cNvPr>
@@ -765,7 +765,7 @@
           <p:cNvPr id="6" name="スライド番号プレースホルダー 5">
             <a:extLst>
               <a:ext uri="{FF2B5EF4-FFF2-40B4-BE49-F238E27FC236}">
-                <a16:creationId xmlns:a16="http://schemas.microsoft.com/office/drawing/2014/main" id="{5FE5C89D-3AEA-184E-8EC0-087D600D7258}"/>
+                <a16:creationId xmlns:a16="http://schemas.microsoft.com/office/drawing/2014/main" id="{DC94D8C9-5762-B4F3-AFC9-D0A3BB9A0B6A}"/>
               </a:ext>
             </a:extLst>
           </p:cNvPr>
@@ -781,7 +781,7 @@
           <a:bodyPr/>
           <a:lstStyle/>
           <a:p>
-            <a:fld id="{8B3C9EF3-6771-44E9-A7A2-47E6107873BF}" type="slidenum">
+            <a:fld id="{6B2941EB-36E4-47D0-8598-D5AE01190ABB}" type="slidenum">
               <a:rPr kumimoji="1" lang="ja-JP" altLang="en-US" smtClean="0"/>
               <a:t>‹#›</a:t>
             </a:fld>
@@ -792,7 +792,7 @@
     </p:spTree>
     <p:extLst>
       <p:ext uri="{BB962C8B-B14F-4D97-AF65-F5344CB8AC3E}">
-        <p14:creationId xmlns:p14="http://schemas.microsoft.com/office/powerpoint/2010/main" val="311384889"/>
+        <p14:creationId xmlns:p14="http://schemas.microsoft.com/office/powerpoint/2010/main" val="3014721772"/>
       </p:ext>
     </p:extLst>
   </p:cSld>
@@ -824,7 +824,7 @@
           <p:cNvPr id="2" name="タイトル 1">
             <a:extLst>
               <a:ext uri="{FF2B5EF4-FFF2-40B4-BE49-F238E27FC236}">
-                <a16:creationId xmlns:a16="http://schemas.microsoft.com/office/drawing/2014/main" id="{454AB460-0D77-74BE-E419-9EA962BF533F}"/>
+                <a16:creationId xmlns:a16="http://schemas.microsoft.com/office/drawing/2014/main" id="{34D7C9B3-C66C-B874-7520-E093EF1C9A51}"/>
               </a:ext>
             </a:extLst>
           </p:cNvPr>
@@ -852,7 +852,7 @@
           <p:cNvPr id="3" name="コンテンツ プレースホルダー 2">
             <a:extLst>
               <a:ext uri="{FF2B5EF4-FFF2-40B4-BE49-F238E27FC236}">
-                <a16:creationId xmlns:a16="http://schemas.microsoft.com/office/drawing/2014/main" id="{790B8D9A-B05C-71DD-92DF-16FE3B42C923}"/>
+                <a16:creationId xmlns:a16="http://schemas.microsoft.com/office/drawing/2014/main" id="{7328FB8A-C258-3E93-E360-281D5B8E0CA3}"/>
               </a:ext>
             </a:extLst>
           </p:cNvPr>
@@ -941,7 +941,7 @@
           <p:cNvPr id="4" name="日付プレースホルダー 3">
             <a:extLst>
               <a:ext uri="{FF2B5EF4-FFF2-40B4-BE49-F238E27FC236}">
-                <a16:creationId xmlns:a16="http://schemas.microsoft.com/office/drawing/2014/main" id="{E9A4ED1A-3F6D-536E-CE15-75F27EB054D0}"/>
+                <a16:creationId xmlns:a16="http://schemas.microsoft.com/office/drawing/2014/main" id="{72366E61-CC05-420C-95CC-7AD784424F6E}"/>
               </a:ext>
             </a:extLst>
           </p:cNvPr>
@@ -957,7 +957,7 @@
           <a:bodyPr/>
           <a:lstStyle/>
           <a:p>
-            <a:fld id="{38CF951B-9A95-4A04-A553-A9E1FF600C98}" type="datetimeFigureOut">
+            <a:fld id="{548A954F-6878-4CBB-85A4-08585DEC05C9}" type="datetimeFigureOut">
               <a:rPr kumimoji="1" lang="ja-JP" altLang="en-US" smtClean="0"/>
               <a:t>2026/7/30</a:t>
             </a:fld>
@@ -970,7 +970,7 @@
           <p:cNvPr id="5" name="フッター プレースホルダー 4">
             <a:extLst>
               <a:ext uri="{FF2B5EF4-FFF2-40B4-BE49-F238E27FC236}">
-                <a16:creationId xmlns:a16="http://schemas.microsoft.com/office/drawing/2014/main" id="{B3932334-80B3-B151-206F-244A4C86735A}"/>
+                <a16:creationId xmlns:a16="http://schemas.microsoft.com/office/drawing/2014/main" id="{0CE58966-3D1E-8DBE-79B7-3E65B872128D}"/>
               </a:ext>
             </a:extLst>
           </p:cNvPr>
@@ -995,7 +995,7 @@
           <p:cNvPr id="6" name="スライド番号プレースホルダー 5">
             <a:extLst>
               <a:ext uri="{FF2B5EF4-FFF2-40B4-BE49-F238E27FC236}">
-                <a16:creationId xmlns:a16="http://schemas.microsoft.com/office/drawing/2014/main" id="{C1C34295-E19F-A8DA-04F1-0384A0E3C9FE}"/>
+                <a16:creationId xmlns:a16="http://schemas.microsoft.com/office/drawing/2014/main" id="{616AABA5-EE36-7490-C4C9-2A830DA8BF63}"/>
               </a:ext>
             </a:extLst>
           </p:cNvPr>
@@ -1011,7 +1011,7 @@
           <a:bodyPr/>
           <a:lstStyle/>
           <a:p>
-            <a:fld id="{8B3C9EF3-6771-44E9-A7A2-47E6107873BF}" type="slidenum">
+            <a:fld id="{6B2941EB-36E4-47D0-8598-D5AE01190ABB}" type="slidenum">
               <a:rPr kumimoji="1" lang="ja-JP" altLang="en-US" smtClean="0"/>
               <a:t>‹#›</a:t>
             </a:fld>
@@ -1022,7 +1022,7 @@
     </p:spTree>
     <p:extLst>
       <p:ext uri="{BB962C8B-B14F-4D97-AF65-F5344CB8AC3E}">
-        <p14:creationId xmlns:p14="http://schemas.microsoft.com/office/powerpoint/2010/main" val="3025664425"/>
+        <p14:creationId xmlns:p14="http://schemas.microsoft.com/office/powerpoint/2010/main" val="2196251433"/>
       </p:ext>
     </p:extLst>
   </p:cSld>
@@ -1054,7 +1054,7 @@
           <p:cNvPr id="2" name="タイトル 1">
             <a:extLst>
               <a:ext uri="{FF2B5EF4-FFF2-40B4-BE49-F238E27FC236}">
-                <a16:creationId xmlns:a16="http://schemas.microsoft.com/office/drawing/2014/main" id="{4A97739A-A5F8-9390-EA57-15DEA942498B}"/>
+                <a16:creationId xmlns:a16="http://schemas.microsoft.com/office/drawing/2014/main" id="{45BD7E0F-61C5-0B79-BB8E-8714BEB0252B}"/>
               </a:ext>
             </a:extLst>
           </p:cNvPr>
@@ -1091,7 +1091,7 @@
           <p:cNvPr id="3" name="テキスト プレースホルダー 2">
             <a:extLst>
               <a:ext uri="{FF2B5EF4-FFF2-40B4-BE49-F238E27FC236}">
-                <a16:creationId xmlns:a16="http://schemas.microsoft.com/office/drawing/2014/main" id="{A8134F45-11DD-156B-DF4C-208515A5B4F8}"/>
+                <a16:creationId xmlns:a16="http://schemas.microsoft.com/office/drawing/2014/main" id="{0055680A-8AC1-7AFE-C4BC-DE83AA5DEB5E}"/>
               </a:ext>
             </a:extLst>
           </p:cNvPr>
@@ -1216,7 +1216,7 @@
           <p:cNvPr id="4" name="日付プレースホルダー 3">
             <a:extLst>
               <a:ext uri="{FF2B5EF4-FFF2-40B4-BE49-F238E27FC236}">
-                <a16:creationId xmlns:a16="http://schemas.microsoft.com/office/drawing/2014/main" id="{39189E1B-3ACE-A9B0-83ED-9E7F658FBF98}"/>
+                <a16:creationId xmlns:a16="http://schemas.microsoft.com/office/drawing/2014/main" id="{29AEDFA0-7958-7655-D10B-B8437EB6FE43}"/>
               </a:ext>
             </a:extLst>
           </p:cNvPr>
@@ -1232,7 +1232,7 @@
           <a:bodyPr/>
           <a:lstStyle/>
           <a:p>
-            <a:fld id="{38CF951B-9A95-4A04-A553-A9E1FF600C98}" type="datetimeFigureOut">
+            <a:fld id="{548A954F-6878-4CBB-85A4-08585DEC05C9}" type="datetimeFigureOut">
               <a:rPr kumimoji="1" lang="ja-JP" altLang="en-US" smtClean="0"/>
               <a:t>2026/7/30</a:t>
             </a:fld>
@@ -1245,7 +1245,7 @@
           <p:cNvPr id="5" name="フッター プレースホルダー 4">
             <a:extLst>
               <a:ext uri="{FF2B5EF4-FFF2-40B4-BE49-F238E27FC236}">
-                <a16:creationId xmlns:a16="http://schemas.microsoft.com/office/drawing/2014/main" id="{0B64EDCB-F279-69FA-5875-081E478431CB}"/>
+                <a16:creationId xmlns:a16="http://schemas.microsoft.com/office/drawing/2014/main" id="{D3A54FC7-53C2-96C8-8A0D-04C8D6583C49}"/>
               </a:ext>
             </a:extLst>
           </p:cNvPr>
@@ -1270,7 +1270,7 @@
           <p:cNvPr id="6" name="スライド番号プレースホルダー 5">
             <a:extLst>
               <a:ext uri="{FF2B5EF4-FFF2-40B4-BE49-F238E27FC236}">
-                <a16:creationId xmlns:a16="http://schemas.microsoft.com/office/drawing/2014/main" id="{E428143C-CDFF-E420-4AB6-57B89EA3A193}"/>
+                <a16:creationId xmlns:a16="http://schemas.microsoft.com/office/drawing/2014/main" id="{0728C0F3-365B-9863-143C-42AC40A34AD9}"/>
               </a:ext>
             </a:extLst>
           </p:cNvPr>
@@ -1286,7 +1286,7 @@
           <a:bodyPr/>
           <a:lstStyle/>
           <a:p>
-            <a:fld id="{8B3C9EF3-6771-44E9-A7A2-47E6107873BF}" type="slidenum">
+            <a:fld id="{6B2941EB-36E4-47D0-8598-D5AE01190ABB}" type="slidenum">
               <a:rPr kumimoji="1" lang="ja-JP" altLang="en-US" smtClean="0"/>
               <a:t>‹#›</a:t>
             </a:fld>
@@ -1297,7 +1297,7 @@
     </p:spTree>
     <p:extLst>
       <p:ext uri="{BB962C8B-B14F-4D97-AF65-F5344CB8AC3E}">
-        <p14:creationId xmlns:p14="http://schemas.microsoft.com/office/powerpoint/2010/main" val="2908067335"/>
+        <p14:creationId xmlns:p14="http://schemas.microsoft.com/office/powerpoint/2010/main" val="3866340255"/>
       </p:ext>
     </p:extLst>
   </p:cSld>
@@ -1329,7 +1329,7 @@
           <p:cNvPr id="2" name="タイトル 1">
             <a:extLst>
               <a:ext uri="{FF2B5EF4-FFF2-40B4-BE49-F238E27FC236}">
-                <a16:creationId xmlns:a16="http://schemas.microsoft.com/office/drawing/2014/main" id="{3D61551B-00AC-A2B8-FD94-86A4219D245F}"/>
+                <a16:creationId xmlns:a16="http://schemas.microsoft.com/office/drawing/2014/main" id="{5362B1BE-850B-6CD7-0CE8-1176CDC6E1FE}"/>
               </a:ext>
             </a:extLst>
           </p:cNvPr>
@@ -1357,7 +1357,7 @@
           <p:cNvPr id="3" name="コンテンツ プレースホルダー 2">
             <a:extLst>
               <a:ext uri="{FF2B5EF4-FFF2-40B4-BE49-F238E27FC236}">
-                <a16:creationId xmlns:a16="http://schemas.microsoft.com/office/drawing/2014/main" id="{696F5679-9A39-391B-4320-7DD96D32E835}"/>
+                <a16:creationId xmlns:a16="http://schemas.microsoft.com/office/drawing/2014/main" id="{A6C55DD7-B014-DF02-061B-4521030A9824}"/>
               </a:ext>
             </a:extLst>
           </p:cNvPr>
@@ -1451,7 +1451,7 @@
           <p:cNvPr id="4" name="コンテンツ プレースホルダー 3">
             <a:extLst>
               <a:ext uri="{FF2B5EF4-FFF2-40B4-BE49-F238E27FC236}">
-                <a16:creationId xmlns:a16="http://schemas.microsoft.com/office/drawing/2014/main" id="{C1F30EAB-395F-FA43-9D94-D58D9C75983C}"/>
+                <a16:creationId xmlns:a16="http://schemas.microsoft.com/office/drawing/2014/main" id="{CB3D71D2-ED60-594E-FE90-8D988DAE980F}"/>
               </a:ext>
             </a:extLst>
           </p:cNvPr>
@@ -1545,7 +1545,7 @@
           <p:cNvPr id="5" name="日付プレースホルダー 4">
             <a:extLst>
               <a:ext uri="{FF2B5EF4-FFF2-40B4-BE49-F238E27FC236}">
-                <a16:creationId xmlns:a16="http://schemas.microsoft.com/office/drawing/2014/main" id="{154CFB2D-C11F-610F-86F8-2CF190431735}"/>
+                <a16:creationId xmlns:a16="http://schemas.microsoft.com/office/drawing/2014/main" id="{FEC10EB2-0BCE-2A1F-D2FF-DBC201BD118D}"/>
               </a:ext>
             </a:extLst>
           </p:cNvPr>
@@ -1561,7 +1561,7 @@
           <a:bodyPr/>
           <a:lstStyle/>
           <a:p>
-            <a:fld id="{38CF951B-9A95-4A04-A553-A9E1FF600C98}" type="datetimeFigureOut">
+            <a:fld id="{548A954F-6878-4CBB-85A4-08585DEC05C9}" type="datetimeFigureOut">
               <a:rPr kumimoji="1" lang="ja-JP" altLang="en-US" smtClean="0"/>
               <a:t>2026/7/30</a:t>
             </a:fld>
@@ -1574,7 +1574,7 @@
           <p:cNvPr id="6" name="フッター プレースホルダー 5">
             <a:extLst>
               <a:ext uri="{FF2B5EF4-FFF2-40B4-BE49-F238E27FC236}">
-                <a16:creationId xmlns:a16="http://schemas.microsoft.com/office/drawing/2014/main" id="{E3AD9469-6B5C-744C-57E0-D58102688462}"/>
+                <a16:creationId xmlns:a16="http://schemas.microsoft.com/office/drawing/2014/main" id="{D0F0644A-0C53-FBE0-0CE5-1B68C9348064}"/>
               </a:ext>
             </a:extLst>
           </p:cNvPr>
@@ -1599,7 +1599,7 @@
           <p:cNvPr id="7" name="スライド番号プレースホルダー 6">
             <a:extLst>
               <a:ext uri="{FF2B5EF4-FFF2-40B4-BE49-F238E27FC236}">
-                <a16:creationId xmlns:a16="http://schemas.microsoft.com/office/drawing/2014/main" id="{BA55F6E3-72C5-6659-2C3E-709B7EF881FE}"/>
+                <a16:creationId xmlns:a16="http://schemas.microsoft.com/office/drawing/2014/main" id="{DFEF56E8-7221-BE87-D783-22EB051D8389}"/>
               </a:ext>
             </a:extLst>
           </p:cNvPr>
@@ -1615,7 +1615,7 @@
           <a:bodyPr/>
           <a:lstStyle/>
           <a:p>
-            <a:fld id="{8B3C9EF3-6771-44E9-A7A2-47E6107873BF}" type="slidenum">
+            <a:fld id="{6B2941EB-36E4-47D0-8598-D5AE01190ABB}" type="slidenum">
               <a:rPr kumimoji="1" lang="ja-JP" altLang="en-US" smtClean="0"/>
               <a:t>‹#›</a:t>
             </a:fld>
@@ -1626,7 +1626,7 @@
     </p:spTree>
     <p:extLst>
       <p:ext uri="{BB962C8B-B14F-4D97-AF65-F5344CB8AC3E}">
-        <p14:creationId xmlns:p14="http://schemas.microsoft.com/office/powerpoint/2010/main" val="2900929983"/>
+        <p14:creationId xmlns:p14="http://schemas.microsoft.com/office/powerpoint/2010/main" val="822162337"/>
       </p:ext>
     </p:extLst>
   </p:cSld>
@@ -1658,7 +1658,7 @@
           <p:cNvPr id="2" name="タイトル 1">
             <a:extLst>
               <a:ext uri="{FF2B5EF4-FFF2-40B4-BE49-F238E27FC236}">
-                <a16:creationId xmlns:a16="http://schemas.microsoft.com/office/drawing/2014/main" id="{79457E70-A791-1AD4-2359-F38E48F6DA51}"/>
+                <a16:creationId xmlns:a16="http://schemas.microsoft.com/office/drawing/2014/main" id="{D3C0E66F-8E83-EADD-7231-19743B9BE720}"/>
               </a:ext>
             </a:extLst>
           </p:cNvPr>
@@ -1691,7 +1691,7 @@
           <p:cNvPr id="3" name="テキスト プレースホルダー 2">
             <a:extLst>
               <a:ext uri="{FF2B5EF4-FFF2-40B4-BE49-F238E27FC236}">
-                <a16:creationId xmlns:a16="http://schemas.microsoft.com/office/drawing/2014/main" id="{1F3AF274-90C5-B3DB-0630-3F88FAD64F5E}"/>
+                <a16:creationId xmlns:a16="http://schemas.microsoft.com/office/drawing/2014/main" id="{3693617B-51BB-882A-9138-B49C08B3DC89}"/>
               </a:ext>
             </a:extLst>
           </p:cNvPr>
@@ -1762,7 +1762,7 @@
           <p:cNvPr id="4" name="コンテンツ プレースホルダー 3">
             <a:extLst>
               <a:ext uri="{FF2B5EF4-FFF2-40B4-BE49-F238E27FC236}">
-                <a16:creationId xmlns:a16="http://schemas.microsoft.com/office/drawing/2014/main" id="{4A94B6CF-6EFF-017D-C88C-01E785395645}"/>
+                <a16:creationId xmlns:a16="http://schemas.microsoft.com/office/drawing/2014/main" id="{170AA2EA-FB85-4C74-0299-18BC609FEEBB}"/>
               </a:ext>
             </a:extLst>
           </p:cNvPr>
@@ -1856,7 +1856,7 @@
           <p:cNvPr id="5" name="テキスト プレースホルダー 4">
             <a:extLst>
               <a:ext uri="{FF2B5EF4-FFF2-40B4-BE49-F238E27FC236}">
-                <a16:creationId xmlns:a16="http://schemas.microsoft.com/office/drawing/2014/main" id="{88D53DC8-154F-B8BD-5B71-D66C161BF3AF}"/>
+                <a16:creationId xmlns:a16="http://schemas.microsoft.com/office/drawing/2014/main" id="{B4D26EC6-A440-D18E-E95D-2A4A82CD8417}"/>
               </a:ext>
             </a:extLst>
           </p:cNvPr>
@@ -1927,7 +1927,7 @@
           <p:cNvPr id="6" name="コンテンツ プレースホルダー 5">
             <a:extLst>
               <a:ext uri="{FF2B5EF4-FFF2-40B4-BE49-F238E27FC236}">
-                <a16:creationId xmlns:a16="http://schemas.microsoft.com/office/drawing/2014/main" id="{F98D5A8F-F1F3-3C45-6ACB-3AB448E36F8A}"/>
+                <a16:creationId xmlns:a16="http://schemas.microsoft.com/office/drawing/2014/main" id="{35E62FAE-0E86-4334-8D23-B97011ACBCEC}"/>
               </a:ext>
             </a:extLst>
           </p:cNvPr>
@@ -2021,7 +2021,7 @@
           <p:cNvPr id="7" name="日付プレースホルダー 6">
             <a:extLst>
               <a:ext uri="{FF2B5EF4-FFF2-40B4-BE49-F238E27FC236}">
-                <a16:creationId xmlns:a16="http://schemas.microsoft.com/office/drawing/2014/main" id="{C26A188B-00A5-00BF-4221-2FE239F2DF36}"/>
+                <a16:creationId xmlns:a16="http://schemas.microsoft.com/office/drawing/2014/main" id="{DE3BF167-6C6A-3120-73C3-C76F2BD17331}"/>
               </a:ext>
             </a:extLst>
           </p:cNvPr>
@@ -2037,7 +2037,7 @@
           <a:bodyPr/>
           <a:lstStyle/>
           <a:p>
-            <a:fld id="{38CF951B-9A95-4A04-A553-A9E1FF600C98}" type="datetimeFigureOut">
+            <a:fld id="{548A954F-6878-4CBB-85A4-08585DEC05C9}" type="datetimeFigureOut">
               <a:rPr kumimoji="1" lang="ja-JP" altLang="en-US" smtClean="0"/>
               <a:t>2026/7/30</a:t>
             </a:fld>
@@ -2050,7 +2050,7 @@
           <p:cNvPr id="8" name="フッター プレースホルダー 7">
             <a:extLst>
               <a:ext uri="{FF2B5EF4-FFF2-40B4-BE49-F238E27FC236}">
-                <a16:creationId xmlns:a16="http://schemas.microsoft.com/office/drawing/2014/main" id="{AB469C15-D101-4336-6E36-71971F78124A}"/>
+                <a16:creationId xmlns:a16="http://schemas.microsoft.com/office/drawing/2014/main" id="{AE8FCFD4-9198-6228-3B05-67D923FEC67E}"/>
               </a:ext>
             </a:extLst>
           </p:cNvPr>
@@ -2075,7 +2075,7 @@
           <p:cNvPr id="9" name="スライド番号プレースホルダー 8">
             <a:extLst>
               <a:ext uri="{FF2B5EF4-FFF2-40B4-BE49-F238E27FC236}">
-                <a16:creationId xmlns:a16="http://schemas.microsoft.com/office/drawing/2014/main" id="{F0871FF0-6FC9-765E-70C7-23C603063E99}"/>
+                <a16:creationId xmlns:a16="http://schemas.microsoft.com/office/drawing/2014/main" id="{428B019B-D3EE-59FF-7D4A-4484489C3553}"/>
               </a:ext>
             </a:extLst>
           </p:cNvPr>
@@ -2091,7 +2091,7 @@
           <a:bodyPr/>
           <a:lstStyle/>
           <a:p>
-            <a:fld id="{8B3C9EF3-6771-44E9-A7A2-47E6107873BF}" type="slidenum">
+            <a:fld id="{6B2941EB-36E4-47D0-8598-D5AE01190ABB}" type="slidenum">
               <a:rPr kumimoji="1" lang="ja-JP" altLang="en-US" smtClean="0"/>
               <a:t>‹#›</a:t>
             </a:fld>
@@ -2102,7 +2102,7 @@
     </p:spTree>
     <p:extLst>
       <p:ext uri="{BB962C8B-B14F-4D97-AF65-F5344CB8AC3E}">
-        <p14:creationId xmlns:p14="http://schemas.microsoft.com/office/powerpoint/2010/main" val="2715550178"/>
+        <p14:creationId xmlns:p14="http://schemas.microsoft.com/office/powerpoint/2010/main" val="2494259117"/>
       </p:ext>
     </p:extLst>
   </p:cSld>
@@ -2134,7 +2134,7 @@
           <p:cNvPr id="2" name="タイトル 1">
             <a:extLst>
               <a:ext uri="{FF2B5EF4-FFF2-40B4-BE49-F238E27FC236}">
-                <a16:creationId xmlns:a16="http://schemas.microsoft.com/office/drawing/2014/main" id="{B050C760-3D7B-A6DB-C54A-B6CF4DD11A30}"/>
+                <a16:creationId xmlns:a16="http://schemas.microsoft.com/office/drawing/2014/main" id="{F9637763-5047-A4CF-3719-EE5667D402E4}"/>
               </a:ext>
             </a:extLst>
           </p:cNvPr>
@@ -2162,7 +2162,7 @@
           <p:cNvPr id="3" name="日付プレースホルダー 2">
             <a:extLst>
               <a:ext uri="{FF2B5EF4-FFF2-40B4-BE49-F238E27FC236}">
-                <a16:creationId xmlns:a16="http://schemas.microsoft.com/office/drawing/2014/main" id="{267200B3-8F99-8D0A-EC10-56C48C0E559C}"/>
+                <a16:creationId xmlns:a16="http://schemas.microsoft.com/office/drawing/2014/main" id="{8D619AD6-F8A4-D393-1013-AE74222F08FA}"/>
               </a:ext>
             </a:extLst>
           </p:cNvPr>
@@ -2178,7 +2178,7 @@
           <a:bodyPr/>
           <a:lstStyle/>
           <a:p>
-            <a:fld id="{38CF951B-9A95-4A04-A553-A9E1FF600C98}" type="datetimeFigureOut">
+            <a:fld id="{548A954F-6878-4CBB-85A4-08585DEC05C9}" type="datetimeFigureOut">
               <a:rPr kumimoji="1" lang="ja-JP" altLang="en-US" smtClean="0"/>
               <a:t>2026/7/30</a:t>
             </a:fld>
@@ -2191,7 +2191,7 @@
           <p:cNvPr id="4" name="フッター プレースホルダー 3">
             <a:extLst>
               <a:ext uri="{FF2B5EF4-FFF2-40B4-BE49-F238E27FC236}">
-                <a16:creationId xmlns:a16="http://schemas.microsoft.com/office/drawing/2014/main" id="{A514DCB1-A313-D73C-BC80-246CA2F3E0C3}"/>
+                <a16:creationId xmlns:a16="http://schemas.microsoft.com/office/drawing/2014/main" id="{83B67A3A-D5D7-48BA-323D-A12E9448E5AB}"/>
               </a:ext>
             </a:extLst>
           </p:cNvPr>
@@ -2216,7 +2216,7 @@
           <p:cNvPr id="5" name="スライド番号プレースホルダー 4">
             <a:extLst>
               <a:ext uri="{FF2B5EF4-FFF2-40B4-BE49-F238E27FC236}">
-                <a16:creationId xmlns:a16="http://schemas.microsoft.com/office/drawing/2014/main" id="{B03E0FBD-9BC6-B467-7F70-942A3A7559EF}"/>
+                <a16:creationId xmlns:a16="http://schemas.microsoft.com/office/drawing/2014/main" id="{21C312EA-728B-F85C-BF42-BA5C92CC6019}"/>
               </a:ext>
             </a:extLst>
           </p:cNvPr>
@@ -2232,7 +2232,7 @@
           <a:bodyPr/>
           <a:lstStyle/>
           <a:p>
-            <a:fld id="{8B3C9EF3-6771-44E9-A7A2-47E6107873BF}" type="slidenum">
+            <a:fld id="{6B2941EB-36E4-47D0-8598-D5AE01190ABB}" type="slidenum">
               <a:rPr kumimoji="1" lang="ja-JP" altLang="en-US" smtClean="0"/>
               <a:t>‹#›</a:t>
             </a:fld>
@@ -2243,7 +2243,7 @@
     </p:spTree>
     <p:extLst>
       <p:ext uri="{BB962C8B-B14F-4D97-AF65-F5344CB8AC3E}">
-        <p14:creationId xmlns:p14="http://schemas.microsoft.com/office/powerpoint/2010/main" val="3659011906"/>
+        <p14:creationId xmlns:p14="http://schemas.microsoft.com/office/powerpoint/2010/main" val="2578242479"/>
       </p:ext>
     </p:extLst>
   </p:cSld>
@@ -2275,7 +2275,7 @@
           <p:cNvPr id="2" name="日付プレースホルダー 1">
             <a:extLst>
               <a:ext uri="{FF2B5EF4-FFF2-40B4-BE49-F238E27FC236}">
-                <a16:creationId xmlns:a16="http://schemas.microsoft.com/office/drawing/2014/main" id="{2018460D-A2FA-68EA-C45C-AED789803FBE}"/>
+                <a16:creationId xmlns:a16="http://schemas.microsoft.com/office/drawing/2014/main" id="{BC0BC18D-F5F2-0073-DEC0-3D592593C7A7}"/>
               </a:ext>
             </a:extLst>
           </p:cNvPr>
@@ -2291,7 +2291,7 @@
           <a:bodyPr/>
           <a:lstStyle/>
           <a:p>
-            <a:fld id="{38CF951B-9A95-4A04-A553-A9E1FF600C98}" type="datetimeFigureOut">
+            <a:fld id="{548A954F-6878-4CBB-85A4-08585DEC05C9}" type="datetimeFigureOut">
               <a:rPr kumimoji="1" lang="ja-JP" altLang="en-US" smtClean="0"/>
               <a:t>2026/7/30</a:t>
             </a:fld>
@@ -2304,7 +2304,7 @@
           <p:cNvPr id="3" name="フッター プレースホルダー 2">
             <a:extLst>
               <a:ext uri="{FF2B5EF4-FFF2-40B4-BE49-F238E27FC236}">
-                <a16:creationId xmlns:a16="http://schemas.microsoft.com/office/drawing/2014/main" id="{25F8B33F-6F54-D148-1E59-D166A45171F7}"/>
+                <a16:creationId xmlns:a16="http://schemas.microsoft.com/office/drawing/2014/main" id="{32116A6B-907F-4EC9-3BB4-5EC60720B900}"/>
               </a:ext>
             </a:extLst>
           </p:cNvPr>
@@ -2329,7 +2329,7 @@
           <p:cNvPr id="4" name="スライド番号プレースホルダー 3">
             <a:extLst>
               <a:ext uri="{FF2B5EF4-FFF2-40B4-BE49-F238E27FC236}">
-                <a16:creationId xmlns:a16="http://schemas.microsoft.com/office/drawing/2014/main" id="{679E1320-0AA4-C8B6-3680-8240CE818F8E}"/>
+                <a16:creationId xmlns:a16="http://schemas.microsoft.com/office/drawing/2014/main" id="{23440B8F-7ECC-D508-6257-4DB928F4CCAC}"/>
               </a:ext>
             </a:extLst>
           </p:cNvPr>
@@ -2345,7 +2345,7 @@
           <a:bodyPr/>
           <a:lstStyle/>
           <a:p>
-            <a:fld id="{8B3C9EF3-6771-44E9-A7A2-47E6107873BF}" type="slidenum">
+            <a:fld id="{6B2941EB-36E4-47D0-8598-D5AE01190ABB}" type="slidenum">
               <a:rPr kumimoji="1" lang="ja-JP" altLang="en-US" smtClean="0"/>
               <a:t>‹#›</a:t>
             </a:fld>
@@ -2356,7 +2356,7 @@
     </p:spTree>
     <p:extLst>
       <p:ext uri="{BB962C8B-B14F-4D97-AF65-F5344CB8AC3E}">
-        <p14:creationId xmlns:p14="http://schemas.microsoft.com/office/powerpoint/2010/main" val="746438809"/>
+        <p14:creationId xmlns:p14="http://schemas.microsoft.com/office/powerpoint/2010/main" val="2207557954"/>
       </p:ext>
     </p:extLst>
   </p:cSld>
@@ -2388,7 +2388,7 @@
           <p:cNvPr id="2" name="タイトル 1">
             <a:extLst>
               <a:ext uri="{FF2B5EF4-FFF2-40B4-BE49-F238E27FC236}">
-                <a16:creationId xmlns:a16="http://schemas.microsoft.com/office/drawing/2014/main" id="{62E0E7D9-6105-2F6D-BB79-13F0422A6077}"/>
+                <a16:creationId xmlns:a16="http://schemas.microsoft.com/office/drawing/2014/main" id="{C3D9FCF9-572E-E8C8-5962-12A89624A3C1}"/>
               </a:ext>
             </a:extLst>
           </p:cNvPr>
@@ -2425,7 +2425,7 @@
           <p:cNvPr id="3" name="コンテンツ プレースホルダー 2">
             <a:extLst>
               <a:ext uri="{FF2B5EF4-FFF2-40B4-BE49-F238E27FC236}">
-                <a16:creationId xmlns:a16="http://schemas.microsoft.com/office/drawing/2014/main" id="{9E1CAB00-5DF8-D3A6-44EC-2B00D693319C}"/>
+                <a16:creationId xmlns:a16="http://schemas.microsoft.com/office/drawing/2014/main" id="{18B7A2FC-B825-2BAA-E116-DB50629023A8}"/>
               </a:ext>
             </a:extLst>
           </p:cNvPr>
@@ -2547,7 +2547,7 @@
           <p:cNvPr id="4" name="テキスト プレースホルダー 3">
             <a:extLst>
               <a:ext uri="{FF2B5EF4-FFF2-40B4-BE49-F238E27FC236}">
-                <a16:creationId xmlns:a16="http://schemas.microsoft.com/office/drawing/2014/main" id="{8A31505D-128D-34EF-EB33-07DB726A0802}"/>
+                <a16:creationId xmlns:a16="http://schemas.microsoft.com/office/drawing/2014/main" id="{43BA0A2C-CFF8-CEBA-91B3-6E6F658FBE94}"/>
               </a:ext>
             </a:extLst>
           </p:cNvPr>
@@ -2618,7 +2618,7 @@
           <p:cNvPr id="5" name="日付プレースホルダー 4">
             <a:extLst>
               <a:ext uri="{FF2B5EF4-FFF2-40B4-BE49-F238E27FC236}">
-                <a16:creationId xmlns:a16="http://schemas.microsoft.com/office/drawing/2014/main" id="{955A4EC3-C969-8979-782C-DDEA06400E08}"/>
+                <a16:creationId xmlns:a16="http://schemas.microsoft.com/office/drawing/2014/main" id="{68F35A44-912C-BAAA-638D-1CE26005D9E7}"/>
               </a:ext>
             </a:extLst>
           </p:cNvPr>
@@ -2634,7 +2634,7 @@
           <a:bodyPr/>
           <a:lstStyle/>
           <a:p>
-            <a:fld id="{38CF951B-9A95-4A04-A553-A9E1FF600C98}" type="datetimeFigureOut">
+            <a:fld id="{548A954F-6878-4CBB-85A4-08585DEC05C9}" type="datetimeFigureOut">
               <a:rPr kumimoji="1" lang="ja-JP" altLang="en-US" smtClean="0"/>
               <a:t>2026/7/30</a:t>
             </a:fld>
@@ -2647,7 +2647,7 @@
           <p:cNvPr id="6" name="フッター プレースホルダー 5">
             <a:extLst>
               <a:ext uri="{FF2B5EF4-FFF2-40B4-BE49-F238E27FC236}">
-                <a16:creationId xmlns:a16="http://schemas.microsoft.com/office/drawing/2014/main" id="{B1C3C4CB-A6FE-895B-A358-2D9BDCB63491}"/>
+                <a16:creationId xmlns:a16="http://schemas.microsoft.com/office/drawing/2014/main" id="{28340A82-C63F-876E-4049-B3D47AE5BFE5}"/>
               </a:ext>
             </a:extLst>
           </p:cNvPr>
@@ -2672,7 +2672,7 @@
           <p:cNvPr id="7" name="スライド番号プレースホルダー 6">
             <a:extLst>
               <a:ext uri="{FF2B5EF4-FFF2-40B4-BE49-F238E27FC236}">
-                <a16:creationId xmlns:a16="http://schemas.microsoft.com/office/drawing/2014/main" id="{15D3379E-009D-F63C-C734-DD17B83A89C9}"/>
+                <a16:creationId xmlns:a16="http://schemas.microsoft.com/office/drawing/2014/main" id="{162401EF-E75B-DE70-17DD-F84F35971F51}"/>
               </a:ext>
             </a:extLst>
           </p:cNvPr>
@@ -2688,7 +2688,7 @@
           <a:bodyPr/>
           <a:lstStyle/>
           <a:p>
-            <a:fld id="{8B3C9EF3-6771-44E9-A7A2-47E6107873BF}" type="slidenum">
+            <a:fld id="{6B2941EB-36E4-47D0-8598-D5AE01190ABB}" type="slidenum">
               <a:rPr kumimoji="1" lang="ja-JP" altLang="en-US" smtClean="0"/>
               <a:t>‹#›</a:t>
             </a:fld>
@@ -2699,7 +2699,7 @@
     </p:spTree>
     <p:extLst>
       <p:ext uri="{BB962C8B-B14F-4D97-AF65-F5344CB8AC3E}">
-        <p14:creationId xmlns:p14="http://schemas.microsoft.com/office/powerpoint/2010/main" val="2193210623"/>
+        <p14:creationId xmlns:p14="http://schemas.microsoft.com/office/powerpoint/2010/main" val="2639997823"/>
       </p:ext>
     </p:extLst>
   </p:cSld>
@@ -2731,7 +2731,7 @@
           <p:cNvPr id="2" name="タイトル 1">
             <a:extLst>
               <a:ext uri="{FF2B5EF4-FFF2-40B4-BE49-F238E27FC236}">
-                <a16:creationId xmlns:a16="http://schemas.microsoft.com/office/drawing/2014/main" id="{6FBE29EF-B04E-D54D-320A-77B8A8A2D61C}"/>
+                <a16:creationId xmlns:a16="http://schemas.microsoft.com/office/drawing/2014/main" id="{20E66B59-00BF-30A1-4CFC-0D68B1DA8AA7}"/>
               </a:ext>
             </a:extLst>
           </p:cNvPr>
@@ -2768,7 +2768,7 @@
           <p:cNvPr id="3" name="図プレースホルダー 2">
             <a:extLst>
               <a:ext uri="{FF2B5EF4-FFF2-40B4-BE49-F238E27FC236}">
-                <a16:creationId xmlns:a16="http://schemas.microsoft.com/office/drawing/2014/main" id="{461EF0EB-DC49-4B6D-EB44-ADCA32FD1C42}"/>
+                <a16:creationId xmlns:a16="http://schemas.microsoft.com/office/drawing/2014/main" id="{185A5041-891A-6783-F890-30A8B9B70D7E}"/>
               </a:ext>
             </a:extLst>
           </p:cNvPr>
@@ -2835,7 +2835,7 @@
           <p:cNvPr id="4" name="テキスト プレースホルダー 3">
             <a:extLst>
               <a:ext uri="{FF2B5EF4-FFF2-40B4-BE49-F238E27FC236}">
-                <a16:creationId xmlns:a16="http://schemas.microsoft.com/office/drawing/2014/main" id="{65387439-AA65-9D26-6DF6-DF10BA5D43D7}"/>
+                <a16:creationId xmlns:a16="http://schemas.microsoft.com/office/drawing/2014/main" id="{7BFEB72F-9619-586D-BC38-6A0038445CDA}"/>
               </a:ext>
             </a:extLst>
           </p:cNvPr>
@@ -2906,7 +2906,7 @@
           <p:cNvPr id="5" name="日付プレースホルダー 4">
             <a:extLst>
               <a:ext uri="{FF2B5EF4-FFF2-40B4-BE49-F238E27FC236}">
-                <a16:creationId xmlns:a16="http://schemas.microsoft.com/office/drawing/2014/main" id="{65B7557B-4989-5B8B-4395-E70DC16D1586}"/>
+                <a16:creationId xmlns:a16="http://schemas.microsoft.com/office/drawing/2014/main" id="{874947A1-B3E4-39EC-DAAA-23537F642FA3}"/>
               </a:ext>
             </a:extLst>
           </p:cNvPr>
@@ -2922,7 +2922,7 @@
           <a:bodyPr/>
           <a:lstStyle/>
           <a:p>
-            <a:fld id="{38CF951B-9A95-4A04-A553-A9E1FF600C98}" type="datetimeFigureOut">
+            <a:fld id="{548A954F-6878-4CBB-85A4-08585DEC05C9}" type="datetimeFigureOut">
               <a:rPr kumimoji="1" lang="ja-JP" altLang="en-US" smtClean="0"/>
               <a:t>2026/7/30</a:t>
             </a:fld>
@@ -2935,7 +2935,7 @@
           <p:cNvPr id="6" name="フッター プレースホルダー 5">
             <a:extLst>
               <a:ext uri="{FF2B5EF4-FFF2-40B4-BE49-F238E27FC236}">
-                <a16:creationId xmlns:a16="http://schemas.microsoft.com/office/drawing/2014/main" id="{9D091082-1216-22EE-9C9C-DBCE6149E6F5}"/>
+                <a16:creationId xmlns:a16="http://schemas.microsoft.com/office/drawing/2014/main" id="{A236F4F2-6A88-452B-58B1-D39F5EE9631F}"/>
               </a:ext>
             </a:extLst>
           </p:cNvPr>
@@ -2960,7 +2960,7 @@
           <p:cNvPr id="7" name="スライド番号プレースホルダー 6">
             <a:extLst>
               <a:ext uri="{FF2B5EF4-FFF2-40B4-BE49-F238E27FC236}">
-                <a16:creationId xmlns:a16="http://schemas.microsoft.com/office/drawing/2014/main" id="{7AC71848-D48A-8978-3887-A27533D9025D}"/>
+                <a16:creationId xmlns:a16="http://schemas.microsoft.com/office/drawing/2014/main" id="{8D92AA51-E2C5-6A63-83C7-5FA9177C59CF}"/>
               </a:ext>
             </a:extLst>
           </p:cNvPr>
@@ -2976,7 +2976,7 @@
           <a:bodyPr/>
           <a:lstStyle/>
           <a:p>
-            <a:fld id="{8B3C9EF3-6771-44E9-A7A2-47E6107873BF}" type="slidenum">
+            <a:fld id="{6B2941EB-36E4-47D0-8598-D5AE01190ABB}" type="slidenum">
               <a:rPr kumimoji="1" lang="ja-JP" altLang="en-US" smtClean="0"/>
               <a:t>‹#›</a:t>
             </a:fld>
@@ -2987,7 +2987,7 @@
     </p:spTree>
     <p:extLst>
       <p:ext uri="{BB962C8B-B14F-4D97-AF65-F5344CB8AC3E}">
-        <p14:creationId xmlns:p14="http://schemas.microsoft.com/office/powerpoint/2010/main" val="3251798886"/>
+        <p14:creationId xmlns:p14="http://schemas.microsoft.com/office/powerpoint/2010/main" val="3050373341"/>
       </p:ext>
     </p:extLst>
   </p:cSld>
@@ -3024,7 +3024,7 @@
           <p:cNvPr id="2" name="タイトル プレースホルダー 1">
             <a:extLst>
               <a:ext uri="{FF2B5EF4-FFF2-40B4-BE49-F238E27FC236}">
-                <a16:creationId xmlns:a16="http://schemas.microsoft.com/office/drawing/2014/main" id="{0F2C755E-B24F-A33F-B684-82C4D2636F08}"/>
+                <a16:creationId xmlns:a16="http://schemas.microsoft.com/office/drawing/2014/main" id="{E740B48B-EC55-5FD7-6B9A-3C04DB7D86DF}"/>
               </a:ext>
             </a:extLst>
           </p:cNvPr>
@@ -3062,7 +3062,7 @@
           <p:cNvPr id="3" name="テキスト プレースホルダー 2">
             <a:extLst>
               <a:ext uri="{FF2B5EF4-FFF2-40B4-BE49-F238E27FC236}">
-                <a16:creationId xmlns:a16="http://schemas.microsoft.com/office/drawing/2014/main" id="{718A6428-39C4-DAAB-018F-F9FC2F2A30A1}"/>
+                <a16:creationId xmlns:a16="http://schemas.microsoft.com/office/drawing/2014/main" id="{8EF927D6-6A8F-63E9-828D-F109D85EAE42}"/>
               </a:ext>
             </a:extLst>
           </p:cNvPr>
@@ -3161,7 +3161,7 @@
           <p:cNvPr id="4" name="日付プレースホルダー 3">
             <a:extLst>
               <a:ext uri="{FF2B5EF4-FFF2-40B4-BE49-F238E27FC236}">
-                <a16:creationId xmlns:a16="http://schemas.microsoft.com/office/drawing/2014/main" id="{07EA9449-2ADD-0C23-5172-1CDB8FA2F044}"/>
+                <a16:creationId xmlns:a16="http://schemas.microsoft.com/office/drawing/2014/main" id="{0E13D9B0-8E9A-E969-64AD-CA0A2F73F3E3}"/>
               </a:ext>
             </a:extLst>
           </p:cNvPr>
@@ -3195,7 +3195,7 @@
             </a:lvl1pPr>
           </a:lstStyle>
           <a:p>
-            <a:fld id="{38CF951B-9A95-4A04-A553-A9E1FF600C98}" type="datetimeFigureOut">
+            <a:fld id="{548A954F-6878-4CBB-85A4-08585DEC05C9}" type="datetimeFigureOut">
               <a:rPr kumimoji="1" lang="ja-JP" altLang="en-US" smtClean="0"/>
               <a:t>2026/7/30</a:t>
             </a:fld>
@@ -3208,7 +3208,7 @@
           <p:cNvPr id="5" name="フッター プレースホルダー 4">
             <a:extLst>
               <a:ext uri="{FF2B5EF4-FFF2-40B4-BE49-F238E27FC236}">
-                <a16:creationId xmlns:a16="http://schemas.microsoft.com/office/drawing/2014/main" id="{A0C7898B-F866-42B6-F9C8-29763887D84E}"/>
+                <a16:creationId xmlns:a16="http://schemas.microsoft.com/office/drawing/2014/main" id="{6C2996CD-1B84-AD3B-1A80-0BE9870DBB71}"/>
               </a:ext>
             </a:extLst>
           </p:cNvPr>
@@ -3251,7 +3251,7 @@
           <p:cNvPr id="6" name="スライド番号プレースホルダー 5">
             <a:extLst>
               <a:ext uri="{FF2B5EF4-FFF2-40B4-BE49-F238E27FC236}">
-                <a16:creationId xmlns:a16="http://schemas.microsoft.com/office/drawing/2014/main" id="{1505A707-B09B-2B84-4C30-E24871103DFB}"/>
+                <a16:creationId xmlns:a16="http://schemas.microsoft.com/office/drawing/2014/main" id="{4F9DB3CB-DDAE-57C8-AA44-268A4E02AEA5}"/>
               </a:ext>
             </a:extLst>
           </p:cNvPr>
@@ -3285,7 +3285,7 @@
             </a:lvl1pPr>
           </a:lstStyle>
           <a:p>
-            <a:fld id="{8B3C9EF3-6771-44E9-A7A2-47E6107873BF}" type="slidenum">
+            <a:fld id="{6B2941EB-36E4-47D0-8598-D5AE01190ABB}" type="slidenum">
               <a:rPr kumimoji="1" lang="ja-JP" altLang="en-US" smtClean="0"/>
               <a:t>‹#›</a:t>
             </a:fld>
@@ -3296,7 +3296,7 @@
     </p:spTree>
     <p:extLst>
       <p:ext uri="{BB962C8B-B14F-4D97-AF65-F5344CB8AC3E}">
-        <p14:creationId xmlns:p14="http://schemas.microsoft.com/office/powerpoint/2010/main" val="1722217002"/>
+        <p14:creationId xmlns:p14="http://schemas.microsoft.com/office/powerpoint/2010/main" val="3549607288"/>
       </p:ext>
     </p:extLst>
   </p:cSld>
@@ -3619,7 +3619,7 @@
           <p:cNvPr id="2" name="テキスト ボックス 1">
             <a:extLst>
               <a:ext uri="{FF2B5EF4-FFF2-40B4-BE49-F238E27FC236}">
-                <a16:creationId xmlns:a16="http://schemas.microsoft.com/office/drawing/2014/main" id="{B27CE582-DF85-E014-56B3-8FB4682331FD}"/>
+                <a16:creationId xmlns:a16="http://schemas.microsoft.com/office/drawing/2014/main" id="{CF1A5742-F671-6475-C8C4-7010CA6087B6}"/>
               </a:ext>
             </a:extLst>
           </p:cNvPr>
@@ -3665,7 +3665,7 @@
           <p:cNvPr id="3" name="テキスト ボックス 2">
             <a:extLst>
               <a:ext uri="{FF2B5EF4-FFF2-40B4-BE49-F238E27FC236}">
-                <a16:creationId xmlns:a16="http://schemas.microsoft.com/office/drawing/2014/main" id="{719D52DB-A39D-0A52-8F1F-15676732E65F}"/>
+                <a16:creationId xmlns:a16="http://schemas.microsoft.com/office/drawing/2014/main" id="{22E8ED05-3FCB-0824-9749-ADF10541BEBF}"/>
               </a:ext>
             </a:extLst>
           </p:cNvPr>
@@ -3711,7 +3711,7 @@
           <p:cNvPr id="4" name="テキスト ボックス 3">
             <a:extLst>
               <a:ext uri="{FF2B5EF4-FFF2-40B4-BE49-F238E27FC236}">
-                <a16:creationId xmlns:a16="http://schemas.microsoft.com/office/drawing/2014/main" id="{55111330-C13B-C7DD-6971-2DF65FFC5EFC}"/>
+                <a16:creationId xmlns:a16="http://schemas.microsoft.com/office/drawing/2014/main" id="{F443CDAC-5D3C-8AE8-EDA5-4168810B28B3}"/>
               </a:ext>
             </a:extLst>
           </p:cNvPr>
@@ -3757,7 +3757,7 @@
           <p:cNvPr id="5" name="テキスト ボックス 4">
             <a:extLst>
               <a:ext uri="{FF2B5EF4-FFF2-40B4-BE49-F238E27FC236}">
-                <a16:creationId xmlns:a16="http://schemas.microsoft.com/office/drawing/2014/main" id="{C5E16A9F-FBD7-D5F9-81E3-4C2B2AB02ABB}"/>
+                <a16:creationId xmlns:a16="http://schemas.microsoft.com/office/drawing/2014/main" id="{86801D57-266A-D7DF-0442-138D5704FC6B}"/>
               </a:ext>
             </a:extLst>
           </p:cNvPr>
@@ -3804,7 +3804,7 @@
             <a:hlinkClick r:id="" action="ppaction://media"/>
             <a:extLst>
               <a:ext uri="{FF2B5EF4-FFF2-40B4-BE49-F238E27FC236}">
-                <a16:creationId xmlns:a16="http://schemas.microsoft.com/office/drawing/2014/main" id="{BA3956AA-F260-6D73-738F-B3D93CA66E92}"/>
+                <a16:creationId xmlns:a16="http://schemas.microsoft.com/office/drawing/2014/main" id="{262557DA-4B99-946A-0CFF-68DAC199FCDE}"/>
               </a:ext>
             </a:extLst>
           </p:cNvPr>
@@ -3839,7 +3839,7 @@
     </p:spTree>
     <p:extLst>
       <p:ext uri="{BB962C8B-B14F-4D97-AF65-F5344CB8AC3E}">
-        <p14:creationId xmlns:p14="http://schemas.microsoft.com/office/powerpoint/2010/main" val="2633752243"/>
+        <p14:creationId xmlns:p14="http://schemas.microsoft.com/office/powerpoint/2010/main" val="2788532313"/>
       </p:ext>
     </p:extLst>
   </p:cSld>
@@ -3963,7 +3963,7 @@
           <p:cNvPr id="2" name="テキスト ボックス 1">
             <a:extLst>
               <a:ext uri="{FF2B5EF4-FFF2-40B4-BE49-F238E27FC236}">
-                <a16:creationId xmlns:a16="http://schemas.microsoft.com/office/drawing/2014/main" id="{077F7E4D-896F-6052-A206-EBF41F0E69AB}"/>
+                <a16:creationId xmlns:a16="http://schemas.microsoft.com/office/drawing/2014/main" id="{CC0EBA27-93E1-C460-D662-8FF8AEBBCEA4}"/>
               </a:ext>
             </a:extLst>
           </p:cNvPr>
@@ -4009,7 +4009,7 @@
           <p:cNvPr id="3" name="テキスト ボックス 2">
             <a:extLst>
               <a:ext uri="{FF2B5EF4-FFF2-40B4-BE49-F238E27FC236}">
-                <a16:creationId xmlns:a16="http://schemas.microsoft.com/office/drawing/2014/main" id="{813BB027-7FC9-52C1-B6BA-DFBA8F1280BA}"/>
+                <a16:creationId xmlns:a16="http://schemas.microsoft.com/office/drawing/2014/main" id="{1851E79B-F743-7F8D-E5CD-B691D21225FA}"/>
               </a:ext>
             </a:extLst>
           </p:cNvPr>
@@ -4055,7 +4055,7 @@
           <p:cNvPr id="4" name="テキスト ボックス 3">
             <a:extLst>
               <a:ext uri="{FF2B5EF4-FFF2-40B4-BE49-F238E27FC236}">
-                <a16:creationId xmlns:a16="http://schemas.microsoft.com/office/drawing/2014/main" id="{DBE9CF34-DAA2-32F6-CBC0-45ABC1F80ECC}"/>
+                <a16:creationId xmlns:a16="http://schemas.microsoft.com/office/drawing/2014/main" id="{B73F6BF7-7774-2421-398F-673B0B719829}"/>
               </a:ext>
             </a:extLst>
           </p:cNvPr>
@@ -4104,7 +4104,7 @@
           <p:cNvPr id="5" name="テキスト ボックス 4">
             <a:extLst>
               <a:ext uri="{FF2B5EF4-FFF2-40B4-BE49-F238E27FC236}">
-                <a16:creationId xmlns:a16="http://schemas.microsoft.com/office/drawing/2014/main" id="{E1C3CAEB-69EE-7FCB-09CF-4AD8C0E040A8}"/>
+                <a16:creationId xmlns:a16="http://schemas.microsoft.com/office/drawing/2014/main" id="{305592BC-2879-04A2-0159-424A1B17153C}"/>
               </a:ext>
             </a:extLst>
           </p:cNvPr>
@@ -4151,7 +4151,7 @@
             <a:hlinkClick r:id="" action="ppaction://media"/>
             <a:extLst>
               <a:ext uri="{FF2B5EF4-FFF2-40B4-BE49-F238E27FC236}">
-                <a16:creationId xmlns:a16="http://schemas.microsoft.com/office/drawing/2014/main" id="{12B31BE8-1F43-1CED-9D0A-54DB643CA2AD}"/>
+                <a16:creationId xmlns:a16="http://schemas.microsoft.com/office/drawing/2014/main" id="{858F3FBA-3883-383A-408E-252F520C8149}"/>
               </a:ext>
             </a:extLst>
           </p:cNvPr>
@@ -4186,7 +4186,7 @@
     </p:spTree>
     <p:extLst>
       <p:ext uri="{BB962C8B-B14F-4D97-AF65-F5344CB8AC3E}">
-        <p14:creationId xmlns:p14="http://schemas.microsoft.com/office/powerpoint/2010/main" val="3451699958"/>
+        <p14:creationId xmlns:p14="http://schemas.microsoft.com/office/powerpoint/2010/main" val="1014860707"/>
       </p:ext>
     </p:extLst>
   </p:cSld>
@@ -4310,7 +4310,7 @@
           <p:cNvPr id="2" name="テキスト ボックス 1">
             <a:extLst>
               <a:ext uri="{FF2B5EF4-FFF2-40B4-BE49-F238E27FC236}">
-                <a16:creationId xmlns:a16="http://schemas.microsoft.com/office/drawing/2014/main" id="{9A92976D-BD23-D781-BA5B-45DC8BB6FCB4}"/>
+                <a16:creationId xmlns:a16="http://schemas.microsoft.com/office/drawing/2014/main" id="{A30183AD-5C27-DD74-480D-87A286B24459}"/>
               </a:ext>
             </a:extLst>
           </p:cNvPr>
@@ -4356,7 +4356,7 @@
           <p:cNvPr id="3" name="テキスト ボックス 2">
             <a:extLst>
               <a:ext uri="{FF2B5EF4-FFF2-40B4-BE49-F238E27FC236}">
-                <a16:creationId xmlns:a16="http://schemas.microsoft.com/office/drawing/2014/main" id="{13E6264D-E416-D231-9E22-482B63AD0D10}"/>
+                <a16:creationId xmlns:a16="http://schemas.microsoft.com/office/drawing/2014/main" id="{91160CC0-CB5C-B8DE-B32F-D6DC7E599F96}"/>
               </a:ext>
             </a:extLst>
           </p:cNvPr>
@@ -4402,7 +4402,7 @@
           <p:cNvPr id="4" name="テキスト ボックス 3">
             <a:extLst>
               <a:ext uri="{FF2B5EF4-FFF2-40B4-BE49-F238E27FC236}">
-                <a16:creationId xmlns:a16="http://schemas.microsoft.com/office/drawing/2014/main" id="{92708B23-6ED9-A478-5BB1-36D727DAE0BB}"/>
+                <a16:creationId xmlns:a16="http://schemas.microsoft.com/office/drawing/2014/main" id="{31509435-FB63-EBC8-F3AB-C397212F397D}"/>
               </a:ext>
             </a:extLst>
           </p:cNvPr>
@@ -4484,7 +4484,7 @@
           <p:cNvPr id="5" name="テキスト ボックス 4">
             <a:extLst>
               <a:ext uri="{FF2B5EF4-FFF2-40B4-BE49-F238E27FC236}">
-                <a16:creationId xmlns:a16="http://schemas.microsoft.com/office/drawing/2014/main" id="{E148423E-E1B9-BBE6-4306-9DB36AD2CB8C}"/>
+                <a16:creationId xmlns:a16="http://schemas.microsoft.com/office/drawing/2014/main" id="{3DFB0C52-73D0-D8DC-A785-127A44075614}"/>
               </a:ext>
             </a:extLst>
           </p:cNvPr>
@@ -4531,7 +4531,7 @@
             <a:hlinkClick r:id="" action="ppaction://media"/>
             <a:extLst>
               <a:ext uri="{FF2B5EF4-FFF2-40B4-BE49-F238E27FC236}">
-                <a16:creationId xmlns:a16="http://schemas.microsoft.com/office/drawing/2014/main" id="{15A95BBC-3AD2-820B-C7C3-20BEB2C497E8}"/>
+                <a16:creationId xmlns:a16="http://schemas.microsoft.com/office/drawing/2014/main" id="{AE0E630F-0071-8CE4-3948-96FAB70F4789}"/>
               </a:ext>
             </a:extLst>
           </p:cNvPr>
@@ -4566,7 +4566,7 @@
     </p:spTree>
     <p:extLst>
       <p:ext uri="{BB962C8B-B14F-4D97-AF65-F5344CB8AC3E}">
-        <p14:creationId xmlns:p14="http://schemas.microsoft.com/office/powerpoint/2010/main" val="1224663703"/>
+        <p14:creationId xmlns:p14="http://schemas.microsoft.com/office/powerpoint/2010/main" val="2358301902"/>
       </p:ext>
     </p:extLst>
   </p:cSld>
@@ -4690,7 +4690,7 @@
           <p:cNvPr id="2" name="テキスト ボックス 1">
             <a:extLst>
               <a:ext uri="{FF2B5EF4-FFF2-40B4-BE49-F238E27FC236}">
-                <a16:creationId xmlns:a16="http://schemas.microsoft.com/office/drawing/2014/main" id="{B6D8A88B-BC90-408D-6F82-9435BD0E3BB0}"/>
+                <a16:creationId xmlns:a16="http://schemas.microsoft.com/office/drawing/2014/main" id="{92639252-D8E8-70C5-1D64-BB93D5CFA471}"/>
               </a:ext>
             </a:extLst>
           </p:cNvPr>
@@ -4736,7 +4736,7 @@
           <p:cNvPr id="3" name="テキスト ボックス 2">
             <a:extLst>
               <a:ext uri="{FF2B5EF4-FFF2-40B4-BE49-F238E27FC236}">
-                <a16:creationId xmlns:a16="http://schemas.microsoft.com/office/drawing/2014/main" id="{27D9E256-947A-3012-2D8E-404D20A8637D}"/>
+                <a16:creationId xmlns:a16="http://schemas.microsoft.com/office/drawing/2014/main" id="{0BD7C497-DCE3-F6E9-3812-658F1DC05BA3}"/>
               </a:ext>
             </a:extLst>
           </p:cNvPr>
@@ -4782,7 +4782,7 @@
           <p:cNvPr id="4" name="テキスト ボックス 3">
             <a:extLst>
               <a:ext uri="{FF2B5EF4-FFF2-40B4-BE49-F238E27FC236}">
-                <a16:creationId xmlns:a16="http://schemas.microsoft.com/office/drawing/2014/main" id="{23DC6F1F-2CD0-A78F-D0BA-3E560F76147A}"/>
+                <a16:creationId xmlns:a16="http://schemas.microsoft.com/office/drawing/2014/main" id="{B3728809-8F6A-10F0-6EA6-671B886D4C88}"/>
               </a:ext>
             </a:extLst>
           </p:cNvPr>
@@ -4828,7 +4828,7 @@
           <p:cNvPr id="5" name="テキスト ボックス 4">
             <a:extLst>
               <a:ext uri="{FF2B5EF4-FFF2-40B4-BE49-F238E27FC236}">
-                <a16:creationId xmlns:a16="http://schemas.microsoft.com/office/drawing/2014/main" id="{89E1463F-3911-CA0E-04AF-51943638A8D3}"/>
+                <a16:creationId xmlns:a16="http://schemas.microsoft.com/office/drawing/2014/main" id="{7FC50C9C-4F93-93E3-1267-FFC256A76035}"/>
               </a:ext>
             </a:extLst>
           </p:cNvPr>
@@ -4875,7 +4875,7 @@
             <a:hlinkClick r:id="" action="ppaction://media"/>
             <a:extLst>
               <a:ext uri="{FF2B5EF4-FFF2-40B4-BE49-F238E27FC236}">
-                <a16:creationId xmlns:a16="http://schemas.microsoft.com/office/drawing/2014/main" id="{F052C2AF-9B9F-21EC-0C2E-454C7540A670}"/>
+                <a16:creationId xmlns:a16="http://schemas.microsoft.com/office/drawing/2014/main" id="{C6FD116C-F86B-DDCC-C3D8-A431FCE1576E}"/>
               </a:ext>
             </a:extLst>
           </p:cNvPr>
@@ -4910,7 +4910,7 @@
     </p:spTree>
     <p:extLst>
       <p:ext uri="{BB962C8B-B14F-4D97-AF65-F5344CB8AC3E}">
-        <p14:creationId xmlns:p14="http://schemas.microsoft.com/office/powerpoint/2010/main" val="1808461680"/>
+        <p14:creationId xmlns:p14="http://schemas.microsoft.com/office/powerpoint/2010/main" val="1091665747"/>
       </p:ext>
     </p:extLst>
   </p:cSld>
@@ -5034,7 +5034,7 @@
           <p:cNvPr id="2" name="テキスト ボックス 1">
             <a:extLst>
               <a:ext uri="{FF2B5EF4-FFF2-40B4-BE49-F238E27FC236}">
-                <a16:creationId xmlns:a16="http://schemas.microsoft.com/office/drawing/2014/main" id="{C7135224-98DA-4A34-6841-957C5FDB6E59}"/>
+                <a16:creationId xmlns:a16="http://schemas.microsoft.com/office/drawing/2014/main" id="{21502931-49D3-647D-CB49-5D3168DD6146}"/>
               </a:ext>
             </a:extLst>
           </p:cNvPr>
@@ -5080,7 +5080,7 @@
           <p:cNvPr id="3" name="テキスト ボックス 2">
             <a:extLst>
               <a:ext uri="{FF2B5EF4-FFF2-40B4-BE49-F238E27FC236}">
-                <a16:creationId xmlns:a16="http://schemas.microsoft.com/office/drawing/2014/main" id="{450FD3DD-89F4-BE49-F8B8-8BC2FFB95167}"/>
+                <a16:creationId xmlns:a16="http://schemas.microsoft.com/office/drawing/2014/main" id="{55165B0A-2C19-DDAC-9A43-C2B23E6679F9}"/>
               </a:ext>
             </a:extLst>
           </p:cNvPr>
@@ -5126,7 +5126,7 @@
           <p:cNvPr id="4" name="テキスト ボックス 3">
             <a:extLst>
               <a:ext uri="{FF2B5EF4-FFF2-40B4-BE49-F238E27FC236}">
-                <a16:creationId xmlns:a16="http://schemas.microsoft.com/office/drawing/2014/main" id="{D140A11E-5DD6-CBF9-C14E-E5100290EA08}"/>
+                <a16:creationId xmlns:a16="http://schemas.microsoft.com/office/drawing/2014/main" id="{FEAE517B-1005-C963-516D-45D0F11B49A1}"/>
               </a:ext>
             </a:extLst>
           </p:cNvPr>
@@ -5172,7 +5172,7 @@
           <p:cNvPr id="5" name="テキスト ボックス 4">
             <a:extLst>
               <a:ext uri="{FF2B5EF4-FFF2-40B4-BE49-F238E27FC236}">
-                <a16:creationId xmlns:a16="http://schemas.microsoft.com/office/drawing/2014/main" id="{5EE05954-17F1-5550-82B6-5C89B80636C3}"/>
+                <a16:creationId xmlns:a16="http://schemas.microsoft.com/office/drawing/2014/main" id="{E39597B9-A833-2685-EAF8-B2EF65BCD92E}"/>
               </a:ext>
             </a:extLst>
           </p:cNvPr>
@@ -5219,7 +5219,7 @@
             <a:hlinkClick r:id="" action="ppaction://media"/>
             <a:extLst>
               <a:ext uri="{FF2B5EF4-FFF2-40B4-BE49-F238E27FC236}">
-                <a16:creationId xmlns:a16="http://schemas.microsoft.com/office/drawing/2014/main" id="{627E01CA-C741-E754-FA15-23B27FC0AA47}"/>
+                <a16:creationId xmlns:a16="http://schemas.microsoft.com/office/drawing/2014/main" id="{2CB372C5-D34A-1E3E-30D2-5C589F2470CB}"/>
               </a:ext>
             </a:extLst>
           </p:cNvPr>
@@ -5254,7 +5254,7 @@
     </p:spTree>
     <p:extLst>
       <p:ext uri="{BB962C8B-B14F-4D97-AF65-F5344CB8AC3E}">
-        <p14:creationId xmlns:p14="http://schemas.microsoft.com/office/powerpoint/2010/main" val="3168546880"/>
+        <p14:creationId xmlns:p14="http://schemas.microsoft.com/office/powerpoint/2010/main" val="2860626785"/>
       </p:ext>
     </p:extLst>
   </p:cSld>
@@ -5378,7 +5378,7 @@
           <p:cNvPr id="2" name="テキスト ボックス 1">
             <a:extLst>
               <a:ext uri="{FF2B5EF4-FFF2-40B4-BE49-F238E27FC236}">
-                <a16:creationId xmlns:a16="http://schemas.microsoft.com/office/drawing/2014/main" id="{4C1DD282-3E68-AEB0-6A5C-274FC09CE283}"/>
+                <a16:creationId xmlns:a16="http://schemas.microsoft.com/office/drawing/2014/main" id="{1E853C12-A9E1-7B21-2A72-742A164AAC62}"/>
               </a:ext>
             </a:extLst>
           </p:cNvPr>
@@ -5424,7 +5424,7 @@
           <p:cNvPr id="3" name="テキスト ボックス 2">
             <a:extLst>
               <a:ext uri="{FF2B5EF4-FFF2-40B4-BE49-F238E27FC236}">
-                <a16:creationId xmlns:a16="http://schemas.microsoft.com/office/drawing/2014/main" id="{92548C97-81FD-68B0-38B3-2E342B27C407}"/>
+                <a16:creationId xmlns:a16="http://schemas.microsoft.com/office/drawing/2014/main" id="{CE9FE4DB-64AD-1B24-0CB3-DA6130C4B526}"/>
               </a:ext>
             </a:extLst>
           </p:cNvPr>
@@ -5470,7 +5470,7 @@
           <p:cNvPr id="4" name="テキスト ボックス 3">
             <a:extLst>
               <a:ext uri="{FF2B5EF4-FFF2-40B4-BE49-F238E27FC236}">
-                <a16:creationId xmlns:a16="http://schemas.microsoft.com/office/drawing/2014/main" id="{C02A555C-AD3C-4748-77E5-AC1FEB16282F}"/>
+                <a16:creationId xmlns:a16="http://schemas.microsoft.com/office/drawing/2014/main" id="{EE4354F0-C12B-D62B-3A83-AF3AA56F583E}"/>
               </a:ext>
             </a:extLst>
           </p:cNvPr>
@@ -5517,7 +5517,7 @@
           <p:cNvPr id="5" name="テキスト ボックス 4">
             <a:extLst>
               <a:ext uri="{FF2B5EF4-FFF2-40B4-BE49-F238E27FC236}">
-                <a16:creationId xmlns:a16="http://schemas.microsoft.com/office/drawing/2014/main" id="{600E379A-4CDA-83C8-5F6C-9166B9DF00EB}"/>
+                <a16:creationId xmlns:a16="http://schemas.microsoft.com/office/drawing/2014/main" id="{485F5193-1870-6F2A-463D-055A3B9B3DA8}"/>
               </a:ext>
             </a:extLst>
           </p:cNvPr>
@@ -5564,7 +5564,7 @@
             <a:hlinkClick r:id="" action="ppaction://media"/>
             <a:extLst>
               <a:ext uri="{FF2B5EF4-FFF2-40B4-BE49-F238E27FC236}">
-                <a16:creationId xmlns:a16="http://schemas.microsoft.com/office/drawing/2014/main" id="{A1236134-3AB7-05A4-5B52-DACFFD156789}"/>
+                <a16:creationId xmlns:a16="http://schemas.microsoft.com/office/drawing/2014/main" id="{F79D4558-4897-FC4E-7C3F-E1CC3EA0B737}"/>
               </a:ext>
             </a:extLst>
           </p:cNvPr>
@@ -5599,7 +5599,7 @@
     </p:spTree>
     <p:extLst>
       <p:ext uri="{BB962C8B-B14F-4D97-AF65-F5344CB8AC3E}">
-        <p14:creationId xmlns:p14="http://schemas.microsoft.com/office/powerpoint/2010/main" val="782596051"/>
+        <p14:creationId xmlns:p14="http://schemas.microsoft.com/office/powerpoint/2010/main" val="449606106"/>
       </p:ext>
     </p:extLst>
   </p:cSld>

</xml_diff>